<commit_message>
Correct the iframe finding: oEmbed works on DubaiSel
Re-tested the live listing today. A bare tour URL in the description is
picked up by DubaiSel's WordPress, which fetches /api/oembed and builds its
own iframe — the tour renders inline at 781x439, all four photos. That
reverses the 2026-09-20 row recording the same method as not picked up; the
earlier result was not reproducible and the cause was not established, so
both rows are kept with the contradiction stated.

So "the iframe never survives" was too strong. Hardening governs what the
poster types, not what the platform chooses to embed. Restated across
COMPAT.md, FINDINGS.md and slide 4 as the trade-off it actually is: the
oEmbed embed shows the tour in place but is sandboxed and reports no
analytics, while the explicit hyperlink leaves the page but is fully
attributed. Inline display or measurement, not both.

The direct link is still the method to build on.

Co-Authored-By: Claude Opus 5 <noreply@anthropic.com>
</commit_message>
<xml_diff>
--- a/deck/DeepVue-Embed-POC.pptx
+++ b/deck/DeepVue-Embed-POC.pptx
@@ -863,7 +863,7 @@
           <a:p>
             <a:r>
               <a:rPr lang="en-US" dirty="0"/>
-              <a:t>The point is not that something failed. The point is that the POC told us which method to build, before Phase 2 was estimated.</a:t>
+              <a:t>The point is not that something failed. Two things were learned: typed HTML is always stripped, and the portal will still embed us if we let its own pipeline do it. Inline display or measurement — on DubaiSel you pick one. The direct link stays the method to build on.</a:t>
             </a:r>
             <a:endParaRPr lang="en-US" dirty="0"/>
           </a:p>
@@ -3904,7 +3904,7 @@
                 <a:ea typeface="Cambria" pitchFamily="34" charset="-122"/>
                 <a:cs typeface="Cambria" pitchFamily="34" charset="-120"/>
               </a:rPr>
-              <a:t>The iframe never survives a description field</a:t>
+              <a:t>Pasted iframe HTML never survives</a:t>
             </a:r>
             <a:endParaRPr lang="en-US" sz="3200" dirty="0"/>
           </a:p>
@@ -3943,7 +3943,7 @@
                 <a:ea typeface="Calibri" pitchFamily="34" charset="-122"/>
                 <a:cs typeface="Calibri" pitchFamily="34" charset="-120"/>
               </a:rPr>
-              <a:t>Six attempts, three platforms, zero successes:</a:t>
+              <a:t>Nothing we typed was accepted — five attempts, zero successes:</a:t>
             </a:r>
             <a:endParaRPr lang="en-US" sz="1400" dirty="0"/>
           </a:p>
@@ -4749,7 +4749,7 @@
                 <a:ea typeface="Calibri" pitchFamily="34" charset="-122"/>
                 <a:cs typeface="Calibri" pitchFamily="34" charset="-120"/>
               </a:rPr>
-              <a:t>DubaiSel — oEmbed</a:t>
+              <a:t>vivaUAE — description</a:t>
             </a:r>
             <a:endParaRPr lang="en-US" sz="1200" dirty="0"/>
           </a:p>
@@ -4788,7 +4788,7 @@
                 <a:ea typeface="Calibri" pitchFamily="34" charset="-122"/>
                 <a:cs typeface="Calibri" pitchFamily="34" charset="-120"/>
               </a:rPr>
-              <a:t>Not picked up</a:t>
+              <a:t>Silently stripped</a:t>
             </a:r>
             <a:endParaRPr lang="en-US" sz="1150" dirty="0"/>
           </a:p>
@@ -4797,175 +4797,6 @@
       <p:sp>
         <p:nvSpPr>
           <p:cNvPr id="30" name="Shape 28"/>
-          <p:cNvSpPr/>
-          <p:nvPr/>
-        </p:nvSpPr>
-        <p:spPr>
-          <a:xfrm>
-            <a:off x="640080" y="5285232"/>
-            <a:ext cx="5760720" cy="548640"/>
-          </a:xfrm>
-          <a:prstGeom prst="roundRect">
-            <a:avLst>
-              <a:gd name="adj" fmla="val 13333"/>
-            </a:avLst>
-          </a:prstGeom>
-          <a:solidFill>
-            <a:srgbClr val="FEF3F2"/>
-          </a:solidFill>
-          <a:ln w="12700">
-            <a:solidFill>
-              <a:srgbClr val="FBD5D2"/>
-            </a:solidFill>
-            <a:prstDash val="solid"/>
-          </a:ln>
-        </p:spPr>
-      </p:sp>
-      <p:sp>
-        <p:nvSpPr>
-          <p:cNvPr id="31" name="Shape 29"/>
-          <p:cNvSpPr/>
-          <p:nvPr/>
-        </p:nvSpPr>
-        <p:spPr>
-          <a:xfrm>
-            <a:off x="841248" y="5385816"/>
-            <a:ext cx="329184" cy="329184"/>
-          </a:xfrm>
-          <a:prstGeom prst="ellipse">
-            <a:avLst/>
-          </a:prstGeom>
-          <a:solidFill>
-            <a:srgbClr val="B42318"/>
-          </a:solidFill>
-          <a:ln w="12700">
-            <a:solidFill>
-              <a:srgbClr val="B42318"/>
-            </a:solidFill>
-            <a:prstDash val="solid"/>
-          </a:ln>
-        </p:spPr>
-      </p:sp>
-      <p:sp>
-        <p:nvSpPr>
-          <p:cNvPr id="32" name="Text 30"/>
-          <p:cNvSpPr txBox="1"/>
-          <p:nvPr/>
-        </p:nvSpPr>
-        <p:spPr>
-          <a:xfrm>
-            <a:off x="841248" y="5385816"/>
-            <a:ext cx="329184" cy="329184"/>
-          </a:xfrm>
-          <a:prstGeom prst="rect">
-            <a:avLst/>
-          </a:prstGeom>
-          <a:noFill/>
-          <a:ln/>
-        </p:spPr>
-        <p:txBody>
-          <a:bodyPr wrap="square" lIns="0" tIns="0" rIns="0" bIns="0" rtlCol="0" anchor="ctr"/>
-          <a:lstStyle/>
-          <a:p>
-            <a:pPr algn="ctr" indent="0" marL="0">
-              <a:buNone/>
-            </a:pPr>
-            <a:r>
-              <a:rPr lang="en-US" sz="1500" b="1" dirty="0">
-                <a:solidFill>
-                  <a:srgbClr val="FFFFFF"/>
-                </a:solidFill>
-                <a:latin typeface="Calibri" pitchFamily="34" charset="0"/>
-                <a:ea typeface="Calibri" pitchFamily="34" charset="-122"/>
-                <a:cs typeface="Calibri" pitchFamily="34" charset="-120"/>
-              </a:rPr>
-              <a:t>✕</a:t>
-            </a:r>
-            <a:endParaRPr lang="en-US" sz="1500" dirty="0"/>
-          </a:p>
-        </p:txBody>
-      </p:sp>
-      <p:sp>
-        <p:nvSpPr>
-          <p:cNvPr id="33" name="Text 31"/>
-          <p:cNvSpPr txBox="1"/>
-          <p:nvPr/>
-        </p:nvSpPr>
-        <p:spPr>
-          <a:xfrm>
-            <a:off x="1298448" y="5340096"/>
-            <a:ext cx="2606040" cy="438912"/>
-          </a:xfrm>
-          <a:prstGeom prst="rect">
-            <a:avLst/>
-          </a:prstGeom>
-          <a:noFill/>
-          <a:ln/>
-        </p:spPr>
-        <p:txBody>
-          <a:bodyPr wrap="square" lIns="0" tIns="0" rIns="0" bIns="0" rtlCol="0" anchor="ctr"/>
-          <a:lstStyle/>
-          <a:p>
-            <a:pPr indent="0" marL="0">
-              <a:buNone/>
-            </a:pPr>
-            <a:r>
-              <a:rPr lang="en-US" sz="1200" b="1" dirty="0">
-                <a:solidFill>
-                  <a:srgbClr val="0E1726"/>
-                </a:solidFill>
-                <a:latin typeface="Calibri" pitchFamily="34" charset="0"/>
-                <a:ea typeface="Calibri" pitchFamily="34" charset="-122"/>
-                <a:cs typeface="Calibri" pitchFamily="34" charset="-120"/>
-              </a:rPr>
-              <a:t>vivaUAE — description</a:t>
-            </a:r>
-            <a:endParaRPr lang="en-US" sz="1200" dirty="0"/>
-          </a:p>
-        </p:txBody>
-      </p:sp>
-      <p:sp>
-        <p:nvSpPr>
-          <p:cNvPr id="34" name="Text 32"/>
-          <p:cNvSpPr txBox="1"/>
-          <p:nvPr/>
-        </p:nvSpPr>
-        <p:spPr>
-          <a:xfrm>
-            <a:off x="3886200" y="5340096"/>
-            <a:ext cx="2377440" cy="438912"/>
-          </a:xfrm>
-          <a:prstGeom prst="rect">
-            <a:avLst/>
-          </a:prstGeom>
-          <a:noFill/>
-          <a:ln/>
-        </p:spPr>
-        <p:txBody>
-          <a:bodyPr wrap="square" lIns="0" tIns="0" rIns="0" bIns="0" rtlCol="0" anchor="ctr"/>
-          <a:lstStyle/>
-          <a:p>
-            <a:pPr algn="r" indent="0" marL="0">
-              <a:buNone/>
-            </a:pPr>
-            <a:r>
-              <a:rPr lang="en-US" sz="1150" dirty="0">
-                <a:solidFill>
-                  <a:srgbClr val="475467"/>
-                </a:solidFill>
-                <a:latin typeface="Calibri" pitchFamily="34" charset="0"/>
-                <a:ea typeface="Calibri" pitchFamily="34" charset="-122"/>
-                <a:cs typeface="Calibri" pitchFamily="34" charset="-120"/>
-              </a:rPr>
-              <a:t>Silently stripped</a:t>
-            </a:r>
-            <a:endParaRPr lang="en-US" sz="1150" dirty="0"/>
-          </a:p>
-        </p:txBody>
-      </p:sp>
-      <p:sp>
-        <p:nvSpPr>
-          <p:cNvPr id="35" name="Shape 33"/>
           <p:cNvSpPr/>
           <p:nvPr/>
         </p:nvSpPr>
@@ -4992,7 +4823,7 @@
       </p:sp>
       <p:sp>
         <p:nvSpPr>
-          <p:cNvPr id="36" name="Text 34"/>
+          <p:cNvPr id="31" name="Text 29"/>
           <p:cNvSpPr txBox="1"/>
           <p:nvPr/>
         </p:nvSpPr>
@@ -5031,7 +4862,7 @@
       </p:sp>
       <p:sp>
         <p:nvSpPr>
-          <p:cNvPr id="37" name="Text 35"/>
+          <p:cNvPr id="32" name="Text 30"/>
           <p:cNvSpPr txBox="1"/>
           <p:nvPr/>
         </p:nvSpPr>
@@ -5070,7 +4901,7 @@
       </p:sp>
       <p:sp>
         <p:nvSpPr>
-          <p:cNvPr id="38" name="Shape 36"/>
+          <p:cNvPr id="33" name="Shape 31"/>
           <p:cNvSpPr/>
           <p:nvPr/>
         </p:nvSpPr>
@@ -5097,7 +4928,7 @@
       </p:sp>
       <p:sp>
         <p:nvSpPr>
-          <p:cNvPr id="39" name="Shape 37"/>
+          <p:cNvPr id="34" name="Shape 32"/>
           <p:cNvSpPr/>
           <p:nvPr/>
         </p:nvSpPr>
@@ -5122,7 +4953,7 @@
       </p:sp>
       <p:sp>
         <p:nvSpPr>
-          <p:cNvPr id="40" name="Text 38"/>
+          <p:cNvPr id="35" name="Text 33"/>
           <p:cNvSpPr txBox="1"/>
           <p:nvPr/>
         </p:nvSpPr>
@@ -5161,7 +4992,7 @@
       </p:sp>
       <p:sp>
         <p:nvSpPr>
-          <p:cNvPr id="41" name="Text 39"/>
+          <p:cNvPr id="36" name="Text 34"/>
           <p:cNvSpPr txBox="1"/>
           <p:nvPr/>
         </p:nvSpPr>
@@ -5192,7 +5023,7 @@
                 <a:ea typeface="Calibri" pitchFamily="34" charset="-122"/>
                 <a:cs typeface="Calibri" pitchFamily="34" charset="-120"/>
               </a:rPr>
-              <a:t>The direct link worked everywhere</a:t>
+              <a:t>But the portal can embed it itself</a:t>
             </a:r>
             <a:endParaRPr lang="en-US" sz="1400" dirty="0"/>
           </a:p>
@@ -5200,30 +5031,30 @@
       </p:sp>
       <p:sp>
         <p:nvSpPr>
-          <p:cNvPr id="42" name="Text 40"/>
+          <p:cNvPr id="37" name="Text 35"/>
           <p:cNvSpPr txBox="1"/>
           <p:nvPr/>
         </p:nvSpPr>
         <p:spPr>
           <a:xfrm>
             <a:off x="7178040" y="5029200"/>
-            <a:ext cx="4023360" cy="896112"/>
-          </a:xfrm>
-          <a:prstGeom prst="rect">
-            <a:avLst/>
-          </a:prstGeom>
-          <a:noFill/>
-          <a:ln/>
-        </p:spPr>
-        <p:txBody>
-          <a:bodyPr wrap="square" lIns="0" tIns="0" rIns="0" bIns="0" rtlCol="0" anchor="ctr"/>
-          <a:lstStyle/>
-          <a:p>
-            <a:pPr indent="0" marL="0">
-              <a:buNone/>
-            </a:pPr>
-            <a:r>
-              <a:rPr lang="en-US" sz="1250" dirty="0">
+            <a:ext cx="4023360" cy="914400"/>
+          </a:xfrm>
+          <a:prstGeom prst="rect">
+            <a:avLst/>
+          </a:prstGeom>
+          <a:noFill/>
+          <a:ln/>
+        </p:spPr>
+        <p:txBody>
+          <a:bodyPr wrap="square" lIns="0" tIns="0" rIns="0" bIns="0" rtlCol="0" anchor="ctr"/>
+          <a:lstStyle/>
+          <a:p>
+            <a:pPr indent="0" marL="0">
+              <a:buNone/>
+            </a:pPr>
+            <a:r>
+              <a:rPr lang="en-US" sz="1150" dirty="0">
                 <a:solidFill>
                   <a:srgbClr val="475467"/>
                 </a:solidFill>
@@ -5231,9 +5062,9 @@
                 <a:ea typeface="Calibri" pitchFamily="34" charset="-122"/>
                 <a:cs typeface="Calibri" pitchFamily="34" charset="-120"/>
               </a:rPr>
-              <a:t>So it becomes the primary method. Inline display stays available on a portal’s own tour field, or a page the agent controls.</a:t>
-            </a:r>
-            <a:endParaRPr lang="en-US" sz="1250" dirty="0"/>
+              <a:t>A bare URL in DubaiSel’s description made its WordPress fetch our oEmbed endpoint and build its own iframe. The tour renders inline on the live listing — but sandboxed, so it reports no analytics.</a:t>
+            </a:r>
+            <a:endParaRPr lang="en-US" sz="1150" dirty="0"/>
           </a:p>
         </p:txBody>
       </p:sp>

</xml_diff>